<commit_message>
Record collision refresh and TOI follow-up diagnostics
</commit_message>
<xml_diff>
--- a/experiments/output/meeting-2026-09-17.pptx
+++ b/experiments/output/meeting-2026-09-17.pptx
@@ -3144,13 +3144,13 @@
                 <c:formatCode>General</c:formatCode>
                 <c:ptCount val="3"/>
                 <c:pt idx="0">
-                  <c:v>4.784</c:v>
+                  <c:v>4.497</c:v>
                 </c:pt>
                 <c:pt idx="1">
-                  <c:v>5.374</c:v>
+                  <c:v>5.311</c:v>
                 </c:pt>
                 <c:pt idx="2">
-                  <c:v>5.792</c:v>
+                  <c:v>5.369</c:v>
                 </c:pt>
               </c:numCache>
             </c:numRef>
@@ -3191,13 +3191,13 @@
                 <c:formatCode>General</c:formatCode>
                 <c:ptCount val="3"/>
                 <c:pt idx="0">
-                  <c:v>5.378</c:v>
+                  <c:v>5.243</c:v>
                 </c:pt>
                 <c:pt idx="1">
-                  <c:v>14.192</c:v>
+                  <c:v>13.991</c:v>
                 </c:pt>
                 <c:pt idx="2">
-                  <c:v>20.454</c:v>
+                  <c:v>20.160</c:v>
                 </c:pt>
               </c:numCache>
             </c:numRef>
@@ -3496,7 +3496,7 @@
                 <a:ea typeface="Arial"/>
                 <a:cs typeface="Arial"/>
               </a:rPr>
-              <a:t>Contact cost rises with cloth layering</a:t>
+              <a:t>Where does the added contact time go?</a:t>
             </a:r>
           </a:p>
         </p:txBody>
@@ -3729,7 +3729,7 @@
                 <a:ea typeface="Arial"/>
                 <a:cs typeface="Arial"/>
               </a:rPr>
-              <a:t>3.53×</a:t>
+              <a:t>3.76×</a:t>
             </a:r>
             <a:endParaRPr sz="5000">
               <a:latin typeface="Helvetica Neue"/>
@@ -4721,7 +4721,7 @@
                 <a:ea typeface="Arial"/>
                 <a:cs typeface="Arial"/>
               </a:rPr>
-              <a:t>Four layers, 16×16 grid</a:t>
+              <a:t>Four layers, 1,156 vertices</a:t>
             </a:r>
           </a:p>
           <a:p xmlns:a="http://schemas.openxmlformats.org/drawingml/2006/main">
@@ -4755,7 +4755,7 @@
                 <a:ea typeface="Arial"/>
                 <a:cs typeface="Arial"/>
               </a:rPr>
-              <a:t>20.45 ms with contact</a:t>
+              <a:t>20.16 ms with contact</a:t>
             </a:r>
           </a:p>
           <a:p xmlns:a="http://schemas.openxmlformats.org/drawingml/2006/main">
@@ -4789,7 +4789,7 @@
                 <a:ea typeface="Arial"/>
                 <a:cs typeface="Arial"/>
               </a:rPr>
-              <a:t>5.79 ms without contact</a:t>
+              <a:t>5.37 ms without contact</a:t>
             </a:r>
           </a:p>
           <a:p xmlns:a="http://schemas.openxmlformats.org/drawingml/2006/main">
@@ -4849,7 +4849,7 @@
                 <a:ea typeface="Arial"/>
                 <a:cs typeface="Arial"/>
               </a:rPr>
-              <a:t>Preliminary scene-family result.</a:t>
+              <a:t>Baseline only; mechanism unproven.</a:t>
             </a:r>
           </a:p>
         </p:txBody>
@@ -5070,7 +5070,7 @@
                 <a:ea typeface="Arial"/>
                 <a:cs typeface="Arial"/>
               </a:rPr>
-              <a:t>Pipeline: 971.1 ms</a:t>
+              <a:t>CCD TOI filter: 20.5 ms</a:t>
             </a:r>
           </a:p>
           <a:p xmlns:a="http://schemas.openxmlformats.org/drawingml/2006/main">
@@ -5125,7 +5125,7 @@
                 <a:ea typeface="Arial"/>
                 <a:cs typeface="Arial"/>
               </a:rPr>
-              <a:t>Together: 33.7% of diagnostic pipeline time over 40 frames.</a:t>
+              <a:t>Pipeline: 971.1 ms over 40 frames.</a:t>
             </a:r>
           </a:p>
           <a:p xmlns:a="http://schemas.openxmlformats.org/drawingml/2006/main">
@@ -5338,7 +5338,7 @@
                 <a:ea typeface="Arial"/>
                 <a:cs typeface="Arial"/>
               </a:rPr>
-              <a:t>Collision search remains material</a:t>
+              <a:t>Candidate search exceeds TOI filtering</a:t>
             </a:r>
           </a:p>
         </p:txBody>
@@ -5622,7 +5622,7 @@
                 <a:ea typeface="Arial"/>
                 <a:cs typeface="Arial"/>
               </a:rPr>
-              <a:t>During contact formation: 21.5% median new pairs between Newton steps (13 nonempty comparisons).</a:t>
+              <a:t>Across six runs, 1 of 246 active-pair DCD calls found no new pair.</a:t>
             </a:r>
           </a:p>
           <a:p xmlns:a="http://schemas.openxmlformats.org/drawingml/2006/main">
@@ -5679,7 +5679,7 @@
                 <a:ea typeface="Arial"/>
                 <a:cs typeface="Arial"/>
               </a:rPr>
-              <a:t>Settled frames 33–40: 0.078% median new pairs across frames, with about 19,400 active pairs.</a:t>
+              <a:t>That exception was an initial DCD call at frame 40 in one run.</a:t>
             </a:r>
           </a:p>
           <a:p xmlns:a="http://schemas.openxmlformats.org/drawingml/2006/main">
@@ -5736,7 +5736,7 @@
                 <a:ea typeface="Arial"/>
                 <a:cs typeface="Arial"/>
               </a:rPr>
-              <a:t>No safe-skip result yet.</a:t>
+              <a:t>Perfect whole-call removal saves under 4% of diagnostic time.</a:t>
             </a:r>
           </a:p>
         </p:txBody>
@@ -5916,7 +5916,7 @@
                 <a:ea typeface="Arial"/>
                 <a:cs typeface="Arial"/>
               </a:rPr>
-              <a:t>Can collision sets be certified across frames?</a:t>
+              <a:t>Can regions avoid rediscovery safely?</a:t>
             </a:r>
           </a:p>
         </p:txBody>
@@ -6334,7 +6334,7 @@
                 <a:ea typeface="Arial"/>
                 <a:cs typeface="Arial"/>
               </a:rPr>
-              <a:t>01  ORACLE</a:t>
+              <a:t>01  DONE</a:t>
             </a:r>
           </a:p>
         </p:txBody>
@@ -7013,7 +7013,7 @@
                 <a:ea typeface="Arial"/>
                 <a:cs typeface="Arial"/>
               </a:rPr>
-              <a:t>Prove regional validity</a:t>
+              <a:t>Measure regional headroom</a:t>
             </a:r>
           </a:p>
           <a:p xmlns:a="http://schemas.openxmlformats.org/drawingml/2006/main">
@@ -7073,7 +7073,7 @@
                 <a:ea typeface="Arial"/>
                 <a:cs typeface="Arial"/>
               </a:rPr>
-              <a:t>Use conservative motion bounds before skipping any rediscovery.</a:t>
+              <a:t>Locate new pairs and bound motion before reusing collision data.</a:t>
             </a:r>
           </a:p>
         </p:txBody>
@@ -7300,7 +7300,7 @@
                 <a:ea typeface="Arial"/>
                 <a:cs typeface="Arial"/>
               </a:rPr>
-              <a:t>Replay baseline pairs</a:t>
+              <a:t>Whole-call oracle: negative</a:t>
             </a:r>
           </a:p>
           <a:p xmlns:a="http://schemas.openxmlformats.org/drawingml/2006/main">
@@ -7360,7 +7360,7 @@
                 <a:ea typeface="Arial"/>
                 <a:cs typeface="Arial"/>
               </a:rPr>
-              <a:t>Measure avoidable DCD work without changing the simulated trajectory.</a:t>
+              <a:t>One zero-new active-contact call in six runs; under 4% diagnostic time.</a:t>
             </a:r>
           </a:p>
         </p:txBody>

</xml_diff>